<commit_message>
Add reasoning tokens and GitHub commit attribution by agent type
Co-authored-by: ms4674 <ms4674@users.noreply.github.com>
</commit_message>
<xml_diff>
--- a/agentic_ai_time_series_2026.pptx
+++ b/agentic_ai_time_series_2026.pptx
@@ -15,6 +15,8 @@
     <p:sldId id="263" r:id="rId14"/>
     <p:sldId id="264" r:id="rId15"/>
     <p:sldId id="265" r:id="rId16"/>
+    <p:sldId id="266" r:id="rId17"/>
+    <p:sldId id="267" r:id="rId18"/>
   </p:sldIdLst>
   <p:sldSz cx="12191695" cy="6858000" type="screen4x3"/>
   <p:notesSz cx="6858000" cy="9144000"/>
@@ -3337,6 +3339,388 @@
               </a:defRPr>
             </a:pPr>
             <a:r>
+              <a:t>Reasoning tokens: now the default mode for agentic work</a:t>
+            </a:r>
+          </a:p>
+        </p:txBody>
+      </p:sp>
+      <p:sp>
+        <p:nvSpPr>
+          <p:cNvPr id="4" name="TextBox 3"/>
+          <p:cNvSpPr txBox="1"/>
+          <p:nvPr/>
+        </p:nvSpPr>
+        <p:spPr>
+          <a:xfrm>
+            <a:off x="502920" y="841248"/>
+            <a:ext cx="11247120" cy="365760"/>
+          </a:xfrm>
+          <a:prstGeom prst="rect">
+            <a:avLst/>
+          </a:prstGeom>
+          <a:noFill/>
+        </p:spPr>
+        <p:txBody>
+          <a:bodyPr wrap="square">
+            <a:spAutoFit/>
+          </a:bodyPr>
+          <a:lstStyle/>
+          <a:p>
+            <a:pPr algn="l">
+              <a:defRPr sz="1300" b="0">
+                <a:solidFill>
+                  <a:srgbClr val="7F7F7F"/>
+                </a:solidFill>
+              </a:defRPr>
+            </a:pPr>
+            <a:r>
+              <a:t>Reasoning-optimized models serve the majority of routed tokens; ~22% of agentic coding task tokens are reasoning</a:t>
+            </a:r>
+          </a:p>
+        </p:txBody>
+      </p:sp>
+      <p:pic>
+        <p:nvPicPr>
+          <p:cNvPr id="5" name="Picture 4" descr="reasoning.png"/>
+          <p:cNvPicPr>
+            <a:picLocks noChangeAspect="1"/>
+          </p:cNvPicPr>
+          <p:nvPr/>
+        </p:nvPicPr>
+        <p:blipFill>
+          <a:blip r:embed="rId2"/>
+          <a:stretch>
+            <a:fillRect/>
+          </a:stretch>
+        </p:blipFill>
+        <p:spPr>
+          <a:xfrm>
+            <a:off x="563727" y="1298448"/>
+            <a:ext cx="11064240" cy="4209221"/>
+          </a:xfrm>
+          <a:prstGeom prst="rect">
+            <a:avLst/>
+          </a:prstGeom>
+        </p:spPr>
+      </p:pic>
+      <p:sp>
+        <p:nvSpPr>
+          <p:cNvPr id="6" name="TextBox 5"/>
+          <p:cNvSpPr txBox="1"/>
+          <p:nvPr/>
+        </p:nvSpPr>
+        <p:spPr>
+          <a:xfrm>
+            <a:off x="502920" y="6446520"/>
+            <a:ext cx="11247120" cy="320040"/>
+          </a:xfrm>
+          <a:prstGeom prst="rect">
+            <a:avLst/>
+          </a:prstGeom>
+          <a:noFill/>
+        </p:spPr>
+        <p:txBody>
+          <a:bodyPr wrap="square">
+            <a:spAutoFit/>
+          </a:bodyPr>
+          <a:lstStyle/>
+          <a:p>
+            <a:pPr algn="l">
+              <a:defRPr sz="1000" b="0">
+                <a:solidFill>
+                  <a:srgbClr val="7F7F7F"/>
+                </a:solidFill>
+              </a:defRPr>
+            </a:pPr>
+            <a:r>
+              <a:t>Source: OpenRouter State of AI; arXiv 2601.14470 Tokenomics study  [#26, 44, 45]  |  # refs -&gt; Sources sheet, agentic_ai_revenue_token_usage_2026.xlsx</a:t>
+            </a:r>
+          </a:p>
+        </p:txBody>
+      </p:sp>
+    </p:spTree>
+  </p:cSld>
+  <p:clrMapOvr>
+    <a:masterClrMapping/>
+  </p:clrMapOvr>
+</p:sld>
+</file>
+
+<file path=ppt/slides/slide11.xml><?xml version="1.0" encoding="utf-8"?>
+<p:sld xmlns:a="http://schemas.openxmlformats.org/drawingml/2006/main" xmlns:p="http://schemas.openxmlformats.org/presentationml/2006/main" xmlns:r="http://schemas.openxmlformats.org/officeDocument/2006/relationships">
+  <p:cSld>
+    <p:spTree>
+      <p:nvGrpSpPr>
+        <p:cNvPr id="1" name=""/>
+        <p:cNvGrpSpPr/>
+        <p:nvPr/>
+      </p:nvGrpSpPr>
+      <p:grpSpPr/>
+      <p:sp>
+        <p:nvSpPr>
+          <p:cNvPr id="2" name="Rectangle 1"/>
+          <p:cNvSpPr/>
+          <p:nvPr/>
+        </p:nvSpPr>
+        <p:spPr>
+          <a:xfrm>
+            <a:off x="0" y="0"/>
+            <a:ext cx="12191695" cy="146304"/>
+          </a:xfrm>
+          <a:prstGeom prst="rect">
+            <a:avLst/>
+          </a:prstGeom>
+          <a:solidFill>
+            <a:srgbClr val="1F3864"/>
+          </a:solidFill>
+          <a:ln>
+            <a:noFill/>
+          </a:ln>
+          <a:effectLst/>
+        </p:spPr>
+        <p:style>
+          <a:lnRef idx="1">
+            <a:schemeClr val="accent1"/>
+          </a:lnRef>
+          <a:fillRef idx="3">
+            <a:schemeClr val="accent1"/>
+          </a:fillRef>
+          <a:effectRef idx="2">
+            <a:schemeClr val="accent1"/>
+          </a:effectRef>
+          <a:fontRef idx="minor">
+            <a:schemeClr val="lt1"/>
+          </a:fontRef>
+        </p:style>
+        <p:txBody>
+          <a:bodyPr rtlCol="0" anchor="ctr"/>
+          <a:lstStyle/>
+          <a:p>
+            <a:pPr algn="ctr"/>
+          </a:p>
+        </p:txBody>
+      </p:sp>
+      <p:sp>
+        <p:nvSpPr>
+          <p:cNvPr id="3" name="TextBox 2"/>
+          <p:cNvSpPr txBox="1"/>
+          <p:nvPr/>
+        </p:nvSpPr>
+        <p:spPr>
+          <a:xfrm>
+            <a:off x="502920" y="292608"/>
+            <a:ext cx="11247120" cy="548640"/>
+          </a:xfrm>
+          <a:prstGeom prst="rect">
+            <a:avLst/>
+          </a:prstGeom>
+          <a:noFill/>
+        </p:spPr>
+        <p:txBody>
+          <a:bodyPr wrap="square">
+            <a:spAutoFit/>
+          </a:bodyPr>
+          <a:lstStyle/>
+          <a:p>
+            <a:pPr algn="l">
+              <a:defRPr sz="2600" b="1">
+                <a:solidFill>
+                  <a:srgbClr val="1F3864"/>
+                </a:solidFill>
+              </a:defRPr>
+            </a:pPr>
+            <a:r>
+              <a:t>Token throughput: the clearest demand signal</a:t>
+            </a:r>
+          </a:p>
+        </p:txBody>
+      </p:sp>
+      <p:sp>
+        <p:nvSpPr>
+          <p:cNvPr id="4" name="TextBox 3"/>
+          <p:cNvSpPr txBox="1"/>
+          <p:nvPr/>
+        </p:nvSpPr>
+        <p:spPr>
+          <a:xfrm>
+            <a:off x="502920" y="841248"/>
+            <a:ext cx="11247120" cy="365760"/>
+          </a:xfrm>
+          <a:prstGeom prst="rect">
+            <a:avLst/>
+          </a:prstGeom>
+          <a:noFill/>
+        </p:spPr>
+        <p:txBody>
+          <a:bodyPr wrap="square">
+            <a:spAutoFit/>
+          </a:bodyPr>
+          <a:lstStyle/>
+          <a:p>
+            <a:pPr algn="l">
+              <a:defRPr sz="1300" b="0">
+                <a:solidFill>
+                  <a:srgbClr val="7F7F7F"/>
+                </a:solidFill>
+              </a:defRPr>
+            </a:pPr>
+            <a:r>
+              <a:t>Google platform-wide monthly tokens, ~330x in two years; agentic workloads are the driver (do not sum reference points)</a:t>
+            </a:r>
+          </a:p>
+        </p:txBody>
+      </p:sp>
+      <p:pic>
+        <p:nvPicPr>
+          <p:cNvPr id="5" name="Picture 4" descr="tokens.png"/>
+          <p:cNvPicPr>
+            <a:picLocks noChangeAspect="1"/>
+          </p:cNvPicPr>
+          <p:nvPr/>
+        </p:nvPicPr>
+        <p:blipFill>
+          <a:blip r:embed="rId2"/>
+          <a:stretch>
+            <a:fillRect/>
+          </a:stretch>
+        </p:blipFill>
+        <p:spPr>
+          <a:xfrm>
+            <a:off x="742865" y="1298448"/>
+            <a:ext cx="10705963" cy="4892040"/>
+          </a:xfrm>
+          <a:prstGeom prst="rect">
+            <a:avLst/>
+          </a:prstGeom>
+        </p:spPr>
+      </p:pic>
+      <p:sp>
+        <p:nvSpPr>
+          <p:cNvPr id="6" name="TextBox 5"/>
+          <p:cNvSpPr txBox="1"/>
+          <p:nvPr/>
+        </p:nvSpPr>
+        <p:spPr>
+          <a:xfrm>
+            <a:off x="502920" y="6446520"/>
+            <a:ext cx="11247120" cy="320040"/>
+          </a:xfrm>
+          <a:prstGeom prst="rect">
+            <a:avLst/>
+          </a:prstGeom>
+          <a:noFill/>
+        </p:spPr>
+        <p:txBody>
+          <a:bodyPr wrap="square">
+            <a:spAutoFit/>
+          </a:bodyPr>
+          <a:lstStyle/>
+          <a:p>
+            <a:pPr algn="l">
+              <a:defRPr sz="1000" b="0">
+                <a:solidFill>
+                  <a:srgbClr val="7F7F7F"/>
+                </a:solidFill>
+              </a:defRPr>
+            </a:pPr>
+            <a:r>
+              <a:t>Source: Google I/O 2026; Q2 2026 earnings; OpenAI DevDay; OpenRouter; Salesforce  [#17, 21, 22, 23, 26]  |  # refs -&gt; Sources sheet, agentic_ai_revenue_token_usage_2026.xlsx</a:t>
+            </a:r>
+          </a:p>
+        </p:txBody>
+      </p:sp>
+    </p:spTree>
+  </p:cSld>
+  <p:clrMapOvr>
+    <a:masterClrMapping/>
+  </p:clrMapOvr>
+</p:sld>
+</file>
+
+<file path=ppt/slides/slide12.xml><?xml version="1.0" encoding="utf-8"?>
+<p:sld xmlns:a="http://schemas.openxmlformats.org/drawingml/2006/main" xmlns:p="http://schemas.openxmlformats.org/presentationml/2006/main" xmlns:r="http://schemas.openxmlformats.org/officeDocument/2006/relationships">
+  <p:cSld>
+    <p:spTree>
+      <p:nvGrpSpPr>
+        <p:cNvPr id="1" name=""/>
+        <p:cNvGrpSpPr/>
+        <p:nvPr/>
+      </p:nvGrpSpPr>
+      <p:grpSpPr/>
+      <p:sp>
+        <p:nvSpPr>
+          <p:cNvPr id="2" name="Rectangle 1"/>
+          <p:cNvSpPr/>
+          <p:nvPr/>
+        </p:nvSpPr>
+        <p:spPr>
+          <a:xfrm>
+            <a:off x="0" y="0"/>
+            <a:ext cx="12191695" cy="146304"/>
+          </a:xfrm>
+          <a:prstGeom prst="rect">
+            <a:avLst/>
+          </a:prstGeom>
+          <a:solidFill>
+            <a:srgbClr val="1F3864"/>
+          </a:solidFill>
+          <a:ln>
+            <a:noFill/>
+          </a:ln>
+          <a:effectLst/>
+        </p:spPr>
+        <p:style>
+          <a:lnRef idx="1">
+            <a:schemeClr val="accent1"/>
+          </a:lnRef>
+          <a:fillRef idx="3">
+            <a:schemeClr val="accent1"/>
+          </a:fillRef>
+          <a:effectRef idx="2">
+            <a:schemeClr val="accent1"/>
+          </a:effectRef>
+          <a:fontRef idx="minor">
+            <a:schemeClr val="lt1"/>
+          </a:fontRef>
+        </p:style>
+        <p:txBody>
+          <a:bodyPr rtlCol="0" anchor="ctr"/>
+          <a:lstStyle/>
+          <a:p>
+            <a:pPr algn="ctr"/>
+          </a:p>
+        </p:txBody>
+      </p:sp>
+      <p:sp>
+        <p:nvSpPr>
+          <p:cNvPr id="3" name="TextBox 2"/>
+          <p:cNvSpPr txBox="1"/>
+          <p:nvPr/>
+        </p:nvSpPr>
+        <p:spPr>
+          <a:xfrm>
+            <a:off x="502920" y="292608"/>
+            <a:ext cx="11247120" cy="548640"/>
+          </a:xfrm>
+          <a:prstGeom prst="rect">
+            <a:avLst/>
+          </a:prstGeom>
+          <a:noFill/>
+        </p:spPr>
+        <p:txBody>
+          <a:bodyPr wrap="square">
+            <a:spAutoFit/>
+          </a:bodyPr>
+          <a:lstStyle/>
+          <a:p>
+            <a:pPr algn="l">
+              <a:defRPr sz="2600" b="1">
+                <a:solidFill>
+                  <a:srgbClr val="1F3864"/>
+                </a:solidFill>
+              </a:defRPr>
+            </a:pPr>
+            <a:r>
               <a:t>Notes, methodology &amp; caveats</a:t>
             </a:r>
           </a:p>
@@ -5168,7 +5552,7 @@
               </a:defRPr>
             </a:pPr>
             <a:r>
-              <a:t>Token throughput: the clearest demand signal</a:t>
+              <a:t>GitHub commits: which agents actually ship code</a:t>
             </a:r>
           </a:p>
         </p:txBody>
@@ -5203,14 +5587,14 @@
               </a:defRPr>
             </a:pPr>
             <a:r>
-              <a:t>Google platform-wide monthly tokens, ~330x in two years; agentic workloads are the driver (do not sum reference points)</a:t>
+              <a:t>Multi-method census of 180M repositories (WoC V2604) plus all-time attribution tracking; channels differ by agent</a:t>
             </a:r>
           </a:p>
         </p:txBody>
       </p:sp>
       <p:pic>
         <p:nvPicPr>
-          <p:cNvPr id="5" name="Picture 4" descr="tokens.png"/>
+          <p:cNvPr id="5" name="Picture 4" descr="github.png"/>
           <p:cNvPicPr>
             <a:picLocks noChangeAspect="1"/>
           </p:cNvPicPr>
@@ -5224,8 +5608,8 @@
         </p:blipFill>
         <p:spPr>
           <a:xfrm>
-            <a:off x="742865" y="1298448"/>
-            <a:ext cx="10705963" cy="4892040"/>
+            <a:off x="563727" y="1298448"/>
+            <a:ext cx="11064240" cy="4069160"/>
           </a:xfrm>
           <a:prstGeom prst="rect">
             <a:avLst/>
@@ -5262,7 +5646,7 @@
               </a:defRPr>
             </a:pPr>
             <a:r>
-              <a:t>Source: Google I/O 2026; Q2 2026 earnings; OpenAI DevDay; OpenRouter; Salesforce  [#17, 21, 22, 23, 26]  |  # refs -&gt; Sources sheet, agentic_ai_revenue_token_usage_2026.xlsx</a:t>
+              <a:t>Source: arXiv 2606.24429 census; Amplifying.ai; JetBrains survey  [#41, 42, 43]  |  # refs -&gt; Sources sheet, agentic_ai_revenue_token_usage_2026.xlsx</a:t>
             </a:r>
           </a:p>
         </p:txBody>

</xml_diff>